<commit_message>
Name the referent instead of pointing back at it
"Make them required" asked the reader to hold the previous item in
memory to know what "them" was. Same for a card titled "Require them",
and for several sentences that opened on "it", "those" or "the setting"
without naming what they pointed at.

Every one of them now names the thing: the step 2 heading reads "Make
the checks from step 1 block a merge", the deck cards read "Run the
checks" and "Require the checks", and the prose says "dismissing stale
approvals", "the file", "machine approval" and "the gate" where it
previously said "it".

No claims changed.

Co-Authored-By: Claude Opus 5 (1M context) <noreply@anthropic.com>
</commit_message>
<xml_diff>
--- a/presentations/what-is-the-second-pair-of-eyes-for-vippsmobilepay.pptx
+++ b/presentations/what-is-the-second-pair-of-eyes-for-vippsmobilepay.pptx
@@ -1584,7 +1584,7 @@
           <a:lstStyle/>
           <a:p>
             <a:r>
-              <a:t>This is chapter 03's dividing line applied to one repository. Everything mechanically verifiable runs before a person looks at the change. Formatting, linting, the test suite and a static analysis pass go in a workflow file under .github/workflows. Dependency scanning is a dependabot.yml. Secret scanning is a toggle in the repository settings. Google's reason is the one from chapter 03: static analysis exists so that human review can focus on what is not mechanically verifiable. The second step is the one people skip. A check that merely runs is advice. In branch protection or a ruleset, require those status checks by name, require a pull request before merging, and stop direct pushes to the default branch. Then dismiss stale approvals when new commits land. That last setting is the cheapest defence in this whole deck against the third failure, where the record says approved and nobody read the version that shipped.</a:t>
+              <a:t>This is chapter 03's dividing line applied to one repository. Everything mechanically verifiable runs before a person looks at the change. Formatting, linting, the test suite and a static analysis pass go in a workflow file under .github/workflows. Dependency scanning is a dependabot.yml. Secret scanning is a toggle in the repository settings. Google's reason is the one from chapter 03: static analysis exists so that human review can focus on what is not mechanically verifiable. The second step is the one people skip. A check that merely runs is advice. In branch protection or a ruleset, require those status checks by name, require a pull request before merging, and stop direct pushes to the default branch. Then dismiss stale approvals when new commits land. Dismissing stale approvals is the cheapest defence in this whole deck against the third failure, where the record says approved and nobody read the version that shipped.</a:t>
             </a:r>
           </a:p>
         </p:txBody>
@@ -17818,7 +17818,7 @@
                 </a:solidFill>
                 <a:latin typeface="Arial"/>
               </a:rPr>
-              <a:t>Run them</a:t>
+              <a:t>Run the checks</a:t>
             </a:r>
           </a:p>
         </p:txBody>
@@ -17994,7 +17994,7 @@
                 </a:solidFill>
                 <a:latin typeface="Arial"/>
               </a:rPr>
-              <a:t>Require them</a:t>
+              <a:t>Require the checks</a:t>
             </a:r>
           </a:p>
         </p:txBody>
@@ -18036,7 +18036,7 @@
                 </a:solidFill>
                 <a:latin typeface="Arial"/>
               </a:rPr>
-              <a:t>Require those checks by name. Require a pull request. Stop direct pushes to the default branch.</a:t>
+              <a:t>Require each check by name. Require a pull request. Stop direct pushes to the default branch.</a:t>
             </a:r>
           </a:p>
         </p:txBody>
@@ -18170,7 +18170,7 @@
                 </a:solidFill>
                 <a:latin typeface="Arial"/>
               </a:rPr>
-              <a:t>Keep them honest</a:t>
+              <a:t>Keep approvals current</a:t>
             </a:r>
           </a:p>
         </p:txBody>

</xml_diff>

<commit_message>
Say where the machine-approval decision gets written
Step 5 said to write the answer "where the next person will look",
which is the same vagueness the headings were just fixed for. It now
names the place: the README, under the same "Review rules" heading step
1 starts, and the step shows the two lines that end up there.

The reason for that location is in the piece already. The setting has
nowhere to hold a reason, and chapter 02 found GitHub's organisation
audit log records no event at all when a machine approves. So the
repository's own README is the only place the decision survives in a
form somebody can read later. Teams that keep decision records can put
the reasoning there and link it, with the README staying the index.

Step 1 now names the same heading, so both answers land together. The
deck's first-week table points at it, and its quote gives the reason
rather than repeating the instruction.

Co-Authored-By: Claude Opus 5 (1M context) <noreply@anthropic.com>
</commit_message>
<xml_diff>
--- a/presentations/what-is-the-second-pair-of-eyes-for-vippsmobilepay.pptx
+++ b/presentations/what-is-the-second-pair-of-eyes-for-vippsmobilepay.pptx
@@ -1725,7 +1725,7 @@
           <a:lstStyle/>
           <a:p>
             <a:r>
-              <a:t>Step 1 settled what the whole repository touches. Both decisions here follow from that answer. A CODEOWNERS file requires a named reviewer for the paths that move money or hold customer data, and leaves the rest on the lighter default. That is the risk-based approach the regulation asks for, written as a file rather than a policy nobody reads. It also answers something the approval rule leaves open: not just that someone approved, but that someone who knows this code did. The second decision comes from chapter 02. Whether Copilot's review counts toward this repository's required approvals is a per-repository choice, currently off by default. Write the answer down where the next person will find it, with the reason. Both repositories are allowed to answer differently. What neither should do is answer by accident, which is what happens when nobody decides.</a:t>
+              <a:t>Step 1 settled what the whole repository touches. Both decisions here follow from that answer. A CODEOWNERS file requires a named reviewer for the paths that move money or hold customer data, and leaves the rest on the lighter default. That is the risk-based approach the regulation asks for, written as a file rather than a policy nobody reads. It also answers something the approval rule leaves open: not just that someone approved, but that someone who knows this code did. The second decision comes from chapter 02. Whether Copilot's review counts toward this repository's required approvals is a per-repository choice, currently off by default. Write the answer into the README under the same Review rules heading step 1 started, with the reason. The setting has nowhere to hold a reason, and chapter 02 found GitHub's organisation audit log records no event at all when a machine approves, so the README is the only place the decision survives. Both repositories are allowed to answer differently. What neither should do is answer by accident, which is what happens when nobody decides.</a:t>
             </a:r>
           </a:p>
         </p:txBody>
@@ -17962,7 +17962,7 @@
                 </a:solidFill>
                 <a:latin typeface="Arial"/>
               </a:rPr>
-              <a:t>Write the answer in the README, with the date</a:t>
+              <a:t>Write the answer in the README, under a short "Review rules" heading</a:t>
             </a:r>
           </a:p>
           <a:p>
@@ -19704,7 +19704,7 @@
                 </a:solidFill>
                 <a:latin typeface="Arial"/>
               </a:rPr>
-              <a:t>Write the second answer down, with the reason. A setting with no owner is a decision nobody made.</a:t>
+              <a:t>Write it in the README next to the tier, with the reason. The setting has nowhere to hold one, and nothing logs a machine approval.</a:t>
             </a:r>
           </a:p>
         </p:txBody>
@@ -20698,7 +20698,7 @@
                           </a:solidFill>
                           <a:latin typeface="Arial"/>
                         </a:rPr>
-                        <a:t>README</a:t>
+                        <a:t>README, under "Review rules"</a:t>
                       </a:r>
                     </a:p>
                   </a:txBody>
@@ -21196,7 +21196,7 @@
                           </a:solidFill>
                           <a:latin typeface="Arial"/>
                         </a:rPr>
-                        <a:t>Written down where the next person looks</a:t>
+                        <a:t>README, under "Review rules"</a:t>
                       </a:r>
                     </a:p>
                   </a:txBody>

</xml_diff>

<commit_message>
Say why step 1 matters, not just what it asks
The step listed what to write down and left the reason implicit. It now
gives two, both already established elsewhere in the piece.

The consequence: every step after this one is stricter or lighter
depending on the answer, and without one the repository gets the same
treatment as every other, whatever it holds.

The obligation: it is the risk assessment the rules ask for, a policy
"based on a risk assessment approach", with nothing said about it
having to be elaborate. That also makes the point that this is cheap.

Both decks carry it. In the PowerPoint this replaces "more than most
repositories have today", the last of the unsupported comparisons, which
had survived there when the HTML deck was cleaned.

Co-Authored-By: Claude Opus 5 (1M context) <noreply@anthropic.com>
</commit_message>
<xml_diff>
--- a/presentations/what-is-the-second-pair-of-eyes-for-vippsmobilepay.pptx
+++ b/presentations/what-is-the-second-pair-of-eyes-for-vippsmobilepay.pptx
@@ -18011,8 +18011,8 @@
         </p:nvSpPr>
         <p:spPr>
           <a:xfrm>
-            <a:off x="548640" y="1780194"/>
-            <a:ext cx="11094415" cy="523697"/>
+            <a:off x="548640" y="1692912"/>
+            <a:ext cx="11094415" cy="785545"/>
           </a:xfrm>
           <a:prstGeom prst="rect">
             <a:avLst/>
@@ -18040,7 +18040,7 @@
                 </a:solidFill>
                 <a:latin typeface="Arial"/>
               </a:rPr>
-              <a:t>Chapter 04 tiered repositories and never said who does the tiering. This repository has to answer for itself, because the answer sets how strict everything after it should be.</a:t>
+              <a:t>Chapter 04 tiered repositories and never said who does the tiering. Every step after this one is stricter or lighter depending on the answer. Without one, this repository gets the same treatment as every other, whatever it holds.</a:t>
             </a:r>
           </a:p>
         </p:txBody>
@@ -18053,7 +18053,7 @@
         </p:nvSpPr>
         <p:spPr>
           <a:xfrm>
-            <a:off x="548640" y="2825100"/>
+            <a:off x="548640" y="2999665"/>
             <a:ext cx="11094415" cy="1389856"/>
           </a:xfrm>
           <a:prstGeom prst="rect">
@@ -18188,7 +18188,7 @@
         </p:nvSpPr>
         <p:spPr>
           <a:xfrm>
-            <a:off x="548640" y="4699588"/>
+            <a:off x="548640" y="4874154"/>
             <a:ext cx="54864" cy="746861"/>
           </a:xfrm>
           <a:prstGeom prst="rect">
@@ -18232,7 +18232,7 @@
         </p:nvSpPr>
         <p:spPr>
           <a:xfrm>
-            <a:off x="822959" y="4791028"/>
+            <a:off x="822959" y="4965594"/>
             <a:ext cx="10682935" cy="563981"/>
           </a:xfrm>
           <a:prstGeom prst="rect">
@@ -18261,7 +18261,7 @@
                 </a:solidFill>
                 <a:latin typeface="Arial"/>
               </a:rPr>
-              <a:t>One sentence in the README that a new joiner can find is more than most repositories have today.</a:t>
+              <a:t>It is also the risk assessment the rules ask for: a policy "based on a risk assessment approach", with nothing said about it having to be elaborate.</a:t>
             </a:r>
           </a:p>
         </p:txBody>

</xml_diff>